<commit_message>
Add Cards layout: heading over four tab-topped cards
Built placeholder-by-placeholder from the unused vertical-text layout:
title (idx 0), four tab heads (idx 1-4) as rounded-top strips filled
accent1-4 with centred bold light text, four body panels (idx 5-8) on
bg2 fill with autofit. All styling lives in the layout, so slides
inherit the card look through normal placeholder inheritance and
author markdown stays plain (head1: "Detect" plus any text content
type in cardN).

Demo slide s03-04 in session 03; renderer suite now 17 passing tests.

Co-Authored-By: Claude Fable 5 <noreply@anthropic.com>
Claude-Session: https://claude.ai/code/session_018XwT8ZFrx9G7kUheEmjTtQ
</commit_message>
<xml_diff>
--- a/examples/template.pptx
+++ b/examples/template.pptx
@@ -348,7 +348,7 @@
 
 <file path=ppt/slideLayouts/slideLayout10.xml><?xml version="1.0" encoding="utf-8"?>
 <p:sldLayout xmlns:a="http://schemas.openxmlformats.org/drawingml/2006/main" xmlns:r="http://schemas.openxmlformats.org/officeDocument/2006/relationships" xmlns:p="http://schemas.openxmlformats.org/presentationml/2006/main" type="vertTx" preserve="1">
-  <p:cSld name="Title and Vertical Text">
+  <p:cSld name="Cards">
     <p:spTree>
       <p:nvGrpSpPr>
         <p:cNvPr id="1" name=""/>
@@ -388,58 +388,6 @@
       </p:sp>
       <p:sp>
         <p:nvSpPr>
-          <p:cNvPr id="3" name="Vertical Text Placeholder 2"/>
-          <p:cNvSpPr>
-            <a:spLocks noGrp="1"/>
-          </p:cNvSpPr>
-          <p:nvPr>
-            <p:ph type="body" orient="vert" idx="1"/>
-          </p:nvPr>
-        </p:nvSpPr>
-        <p:spPr/>
-        <p:txBody>
-          <a:bodyPr vert="eaVert"/>
-          <a:lstStyle/>
-          <a:p>
-            <a:pPr lvl="0"/>
-            <a:r>
-              <a:rPr lang="en-US" smtClean="0"/>
-              <a:t>Click to edit Master text styles</a:t>
-            </a:r>
-          </a:p>
-          <a:p>
-            <a:pPr lvl="1"/>
-            <a:r>
-              <a:rPr lang="en-US" smtClean="0"/>
-              <a:t>Second level</a:t>
-            </a:r>
-          </a:p>
-          <a:p>
-            <a:pPr lvl="2"/>
-            <a:r>
-              <a:rPr lang="en-US" smtClean="0"/>
-              <a:t>Third level</a:t>
-            </a:r>
-          </a:p>
-          <a:p>
-            <a:pPr lvl="3"/>
-            <a:r>
-              <a:rPr lang="en-US" smtClean="0"/>
-              <a:t>Fourth level</a:t>
-            </a:r>
-          </a:p>
-          <a:p>
-            <a:pPr lvl="4"/>
-            <a:r>
-              <a:rPr lang="en-US" smtClean="0"/>
-              <a:t>Fifth level</a:t>
-            </a:r>
-            <a:endParaRPr lang="en-US"/>
-          </a:p>
-        </p:txBody>
-      </p:sp>
-      <p:sp>
-        <p:nvSpPr>
           <p:cNvPr id="4" name="Date Placeholder 3"/>
           <p:cNvSpPr>
             <a:spLocks noGrp="1"/>
@@ -500,6 +448,330 @@
               <a:t>‹#›</a:t>
             </a:fld>
             <a:endParaRPr lang="en-US"/>
+          </a:p>
+        </p:txBody>
+      </p:sp>
+      <p:sp>
+        <p:nvSpPr>
+          <p:cNvPr id="21" name="Card 1 Tab"/>
+          <p:cNvSpPr>
+            <a:spLocks noGrp="1"/>
+          </p:cNvSpPr>
+          <p:nvPr>
+            <p:ph type="body" sz="quarter" idx="1"/>
+          </p:nvPr>
+        </p:nvSpPr>
+        <p:spPr>
+          <a:xfrm>
+            <a:off x="301752" y="1645920"/>
+            <a:ext cx="2018538" cy="502920"/>
+          </a:xfrm>
+          <a:prstGeom prst="round2SameRect">
+            <a:avLst>
+              <a:gd name="adj1" fmla="val 25000"/>
+              <a:gd name="adj2" fmla="val 0"/>
+            </a:avLst>
+          </a:prstGeom>
+          <a:solidFill>
+            <a:schemeClr val="accent1"/>
+          </a:solidFill>
+        </p:spPr>
+        <p:txBody>
+          <a:bodyPr anchor="ctr" lIns="91440" rIns="91440" tIns="0" bIns="0"/>
+          <a:lstStyle>
+            <a:lvl1pPr algn="ctr" marL="0" indent="0">
+              <a:buNone/>
+              <a:defRPr sz="1500" b="1">
+                <a:solidFill>
+                  <a:schemeClr val="lt1"/>
+                </a:solidFill>
+              </a:defRPr>
+            </a:lvl1pPr>
+          </a:lstStyle>
+          <a:p>
+            <a:endParaRPr/>
+          </a:p>
+        </p:txBody>
+      </p:sp>
+      <p:sp>
+        <p:nvSpPr>
+          <p:cNvPr id="25" name="Card 1 Body"/>
+          <p:cNvSpPr>
+            <a:spLocks noGrp="1"/>
+          </p:cNvSpPr>
+          <p:nvPr>
+            <p:ph type="body" sz="quarter" idx="5"/>
+          </p:nvPr>
+        </p:nvSpPr>
+        <p:spPr>
+          <a:xfrm>
+            <a:off x="301752" y="2148840"/>
+            <a:ext cx="2018538" cy="4343400"/>
+          </a:xfrm>
+          <a:prstGeom prst="rect">
+            <a:avLst/>
+          </a:prstGeom>
+          <a:solidFill>
+            <a:schemeClr val="bg2"/>
+          </a:solidFill>
+        </p:spPr>
+        <p:txBody>
+          <a:bodyPr lIns="91440" rIns="91440" tIns="82296" bIns="82296">
+            <a:normAutofit/>
+          </a:bodyPr>
+          <a:lstStyle>
+            <a:lvl1pPr>
+              <a:defRPr sz="1300"/>
+            </a:lvl1pPr>
+            <a:lvl2pPr>
+              <a:defRPr sz="1100"/>
+            </a:lvl2pPr>
+          </a:lstStyle>
+          <a:p>
+            <a:endParaRPr/>
+          </a:p>
+        </p:txBody>
+      </p:sp>
+      <p:sp>
+        <p:nvSpPr>
+          <p:cNvPr id="22" name="Card 2 Tab"/>
+          <p:cNvSpPr>
+            <a:spLocks noGrp="1"/>
+          </p:cNvSpPr>
+          <p:nvPr>
+            <p:ph type="body" sz="quarter" idx="2"/>
+          </p:nvPr>
+        </p:nvSpPr>
+        <p:spPr>
+          <a:xfrm>
+            <a:off x="2475738" y="1645920"/>
+            <a:ext cx="2018538" cy="502920"/>
+          </a:xfrm>
+          <a:prstGeom prst="round2SameRect">
+            <a:avLst>
+              <a:gd name="adj1" fmla="val 25000"/>
+              <a:gd name="adj2" fmla="val 0"/>
+            </a:avLst>
+          </a:prstGeom>
+          <a:solidFill>
+            <a:schemeClr val="accent2"/>
+          </a:solidFill>
+        </p:spPr>
+        <p:txBody>
+          <a:bodyPr anchor="ctr" lIns="91440" rIns="91440" tIns="0" bIns="0"/>
+          <a:lstStyle>
+            <a:lvl1pPr algn="ctr" marL="0" indent="0">
+              <a:buNone/>
+              <a:defRPr sz="1500" b="1">
+                <a:solidFill>
+                  <a:schemeClr val="lt1"/>
+                </a:solidFill>
+              </a:defRPr>
+            </a:lvl1pPr>
+          </a:lstStyle>
+          <a:p>
+            <a:endParaRPr/>
+          </a:p>
+        </p:txBody>
+      </p:sp>
+      <p:sp>
+        <p:nvSpPr>
+          <p:cNvPr id="26" name="Card 2 Body"/>
+          <p:cNvSpPr>
+            <a:spLocks noGrp="1"/>
+          </p:cNvSpPr>
+          <p:nvPr>
+            <p:ph type="body" sz="quarter" idx="6"/>
+          </p:nvPr>
+        </p:nvSpPr>
+        <p:spPr>
+          <a:xfrm>
+            <a:off x="2475738" y="2148840"/>
+            <a:ext cx="2018538" cy="4343400"/>
+          </a:xfrm>
+          <a:prstGeom prst="rect">
+            <a:avLst/>
+          </a:prstGeom>
+          <a:solidFill>
+            <a:schemeClr val="bg2"/>
+          </a:solidFill>
+        </p:spPr>
+        <p:txBody>
+          <a:bodyPr lIns="91440" rIns="91440" tIns="82296" bIns="82296">
+            <a:normAutofit/>
+          </a:bodyPr>
+          <a:lstStyle>
+            <a:lvl1pPr>
+              <a:defRPr sz="1300"/>
+            </a:lvl1pPr>
+            <a:lvl2pPr>
+              <a:defRPr sz="1100"/>
+            </a:lvl2pPr>
+          </a:lstStyle>
+          <a:p>
+            <a:endParaRPr/>
+          </a:p>
+        </p:txBody>
+      </p:sp>
+      <p:sp>
+        <p:nvSpPr>
+          <p:cNvPr id="23" name="Card 3 Tab"/>
+          <p:cNvSpPr>
+            <a:spLocks noGrp="1"/>
+          </p:cNvSpPr>
+          <p:nvPr>
+            <p:ph type="body" sz="quarter" idx="3"/>
+          </p:nvPr>
+        </p:nvSpPr>
+        <p:spPr>
+          <a:xfrm>
+            <a:off x="4649724" y="1645920"/>
+            <a:ext cx="2018538" cy="502920"/>
+          </a:xfrm>
+          <a:prstGeom prst="round2SameRect">
+            <a:avLst>
+              <a:gd name="adj1" fmla="val 25000"/>
+              <a:gd name="adj2" fmla="val 0"/>
+            </a:avLst>
+          </a:prstGeom>
+          <a:solidFill>
+            <a:schemeClr val="accent3"/>
+          </a:solidFill>
+        </p:spPr>
+        <p:txBody>
+          <a:bodyPr anchor="ctr" lIns="91440" rIns="91440" tIns="0" bIns="0"/>
+          <a:lstStyle>
+            <a:lvl1pPr algn="ctr" marL="0" indent="0">
+              <a:buNone/>
+              <a:defRPr sz="1500" b="1">
+                <a:solidFill>
+                  <a:schemeClr val="lt1"/>
+                </a:solidFill>
+              </a:defRPr>
+            </a:lvl1pPr>
+          </a:lstStyle>
+          <a:p>
+            <a:endParaRPr/>
+          </a:p>
+        </p:txBody>
+      </p:sp>
+      <p:sp>
+        <p:nvSpPr>
+          <p:cNvPr id="27" name="Card 3 Body"/>
+          <p:cNvSpPr>
+            <a:spLocks noGrp="1"/>
+          </p:cNvSpPr>
+          <p:nvPr>
+            <p:ph type="body" sz="quarter" idx="7"/>
+          </p:nvPr>
+        </p:nvSpPr>
+        <p:spPr>
+          <a:xfrm>
+            <a:off x="4649724" y="2148840"/>
+            <a:ext cx="2018538" cy="4343400"/>
+          </a:xfrm>
+          <a:prstGeom prst="rect">
+            <a:avLst/>
+          </a:prstGeom>
+          <a:solidFill>
+            <a:schemeClr val="bg2"/>
+          </a:solidFill>
+        </p:spPr>
+        <p:txBody>
+          <a:bodyPr lIns="91440" rIns="91440" tIns="82296" bIns="82296">
+            <a:normAutofit/>
+          </a:bodyPr>
+          <a:lstStyle>
+            <a:lvl1pPr>
+              <a:defRPr sz="1300"/>
+            </a:lvl1pPr>
+            <a:lvl2pPr>
+              <a:defRPr sz="1100"/>
+            </a:lvl2pPr>
+          </a:lstStyle>
+          <a:p>
+            <a:endParaRPr/>
+          </a:p>
+        </p:txBody>
+      </p:sp>
+      <p:sp>
+        <p:nvSpPr>
+          <p:cNvPr id="24" name="Card 4 Tab"/>
+          <p:cNvSpPr>
+            <a:spLocks noGrp="1"/>
+          </p:cNvSpPr>
+          <p:nvPr>
+            <p:ph type="body" sz="quarter" idx="4"/>
+          </p:nvPr>
+        </p:nvSpPr>
+        <p:spPr>
+          <a:xfrm>
+            <a:off x="6823710" y="1645920"/>
+            <a:ext cx="2018538" cy="502920"/>
+          </a:xfrm>
+          <a:prstGeom prst="round2SameRect">
+            <a:avLst>
+              <a:gd name="adj1" fmla="val 25000"/>
+              <a:gd name="adj2" fmla="val 0"/>
+            </a:avLst>
+          </a:prstGeom>
+          <a:solidFill>
+            <a:schemeClr val="accent4"/>
+          </a:solidFill>
+        </p:spPr>
+        <p:txBody>
+          <a:bodyPr anchor="ctr" lIns="91440" rIns="91440" tIns="0" bIns="0"/>
+          <a:lstStyle>
+            <a:lvl1pPr algn="ctr" marL="0" indent="0">
+              <a:buNone/>
+              <a:defRPr sz="1500" b="1">
+                <a:solidFill>
+                  <a:schemeClr val="lt1"/>
+                </a:solidFill>
+              </a:defRPr>
+            </a:lvl1pPr>
+          </a:lstStyle>
+          <a:p>
+            <a:endParaRPr/>
+          </a:p>
+        </p:txBody>
+      </p:sp>
+      <p:sp>
+        <p:nvSpPr>
+          <p:cNvPr id="28" name="Card 4 Body"/>
+          <p:cNvSpPr>
+            <a:spLocks noGrp="1"/>
+          </p:cNvSpPr>
+          <p:nvPr>
+            <p:ph type="body" sz="quarter" idx="8"/>
+          </p:nvPr>
+        </p:nvSpPr>
+        <p:spPr>
+          <a:xfrm>
+            <a:off x="6823710" y="2148840"/>
+            <a:ext cx="2018538" cy="4343400"/>
+          </a:xfrm>
+          <a:prstGeom prst="rect">
+            <a:avLst/>
+          </a:prstGeom>
+          <a:solidFill>
+            <a:schemeClr val="bg2"/>
+          </a:solidFill>
+        </p:spPr>
+        <p:txBody>
+          <a:bodyPr lIns="91440" rIns="91440" tIns="82296" bIns="82296">
+            <a:normAutofit/>
+          </a:bodyPr>
+          <a:lstStyle>
+            <a:lvl1pPr>
+              <a:defRPr sz="1300"/>
+            </a:lvl1pPr>
+            <a:lvl2pPr>
+              <a:defRPr sz="1100"/>
+            </a:lvl2pPr>
+          </a:lstStyle>
+          <a:p>
+            <a:endParaRPr/>
           </a:p>
         </p:txBody>
       </p:sp>

</xml_diff>